<commit_message>
chore(executive_board): sync api hooks and metadata
</commit_message>
<xml_diff>
--- a/src/pptx_generator/executive_board/input/executive_board.pptx
+++ b/src/pptx_generator/executive_board/input/executive_board.pptx
@@ -7264,7 +7264,7 @@
       </p:sp>
       <p:sp>
         <p:nvSpPr>
-          <p:cNvPr id="12" name="テキスト プレースホルダー 32">
+          <p:cNvPr id="12" name="テキスト プレースホルダー 33">
             <a:extLst>
               <a:ext uri="{FF2B5EF4-FFF2-40B4-BE49-F238E27FC236}">
                 <a16:creationId xmlns:a16="http://schemas.microsoft.com/office/drawing/2014/main" id="{767B8674-FB4E-49D8-B7D3-1BA8A8BB62AC}"/>
@@ -8141,7 +8141,7 @@
       </p:sp>
       <p:sp>
         <p:nvSpPr>
-          <p:cNvPr id="11" name="テキスト プレースホルダー 32">
+          <p:cNvPr id="11" name="テキスト プレースホルダー 33">
             <a:extLst>
               <a:ext uri="{FF2B5EF4-FFF2-40B4-BE49-F238E27FC236}">
                 <a16:creationId xmlns:a16="http://schemas.microsoft.com/office/drawing/2014/main" id="{6FB8F6DA-1F3E-4E7B-89E0-428507B0F217}"/>
@@ -9134,7 +9134,7 @@
       </p:sp>
       <p:sp>
         <p:nvSpPr>
-          <p:cNvPr id="11" name="テキスト プレースホルダー 32">
+          <p:cNvPr id="11" name="テキスト プレースホルダー 33">
             <a:extLst>
               <a:ext uri="{FF2B5EF4-FFF2-40B4-BE49-F238E27FC236}">
                 <a16:creationId xmlns:a16="http://schemas.microsoft.com/office/drawing/2014/main" id="{CB065E3A-67FC-4775-A9B8-E90F1C103D1F}"/>
@@ -10058,7 +10058,7 @@
       </p:sp>
       <p:sp>
         <p:nvSpPr>
-          <p:cNvPr id="11" name="テキスト プレースホルダー 32">
+          <p:cNvPr id="11" name="テキスト プレースホルダー 33">
             <a:extLst>
               <a:ext uri="{FF2B5EF4-FFF2-40B4-BE49-F238E27FC236}">
                 <a16:creationId xmlns:a16="http://schemas.microsoft.com/office/drawing/2014/main" id="{6FB8F6DA-1F3E-4E7B-89E0-428507B0F217}"/>
@@ -24039,6 +24039,26 @@
 </file>
 
 <file path=customXml/item1.xml><?xml version="1.0" encoding="utf-8"?>
+<p:properties xmlns:p="http://schemas.microsoft.com/office/2006/metadata/properties" xmlns:xsi="http://www.w3.org/2001/XMLSchema-instance" xmlns:pc="http://schemas.microsoft.com/office/infopath/2007/PartnerControls">
+  <documentManagement>
+    <lcf76f155ced4ddcb4097134ff3c332f xmlns="fda3c21f-1c89-4c79-bdc1-51a203d16466">
+      <Terms xmlns="http://schemas.microsoft.com/office/infopath/2007/PartnerControls"/>
+    </lcf76f155ced4ddcb4097134ff3c332f>
+    <TaxCatchAll xmlns="32cc87eb-95ee-46b2-8a4f-e4c19d67f474" xsi:nil="true"/>
+  </documentManagement>
+</p:properties>
+</file>
+
+<file path=customXml/item2.xml><?xml version="1.0" encoding="utf-8"?>
+<?mso-contentType ?>
+<FormTemplates xmlns="http://schemas.microsoft.com/sharepoint/v3/contenttype/forms">
+  <Display>DocumentLibraryForm</Display>
+  <Edit>DocumentLibraryForm</Edit>
+  <New>DocumentLibraryForm</New>
+</FormTemplates>
+</file>
+
+<file path=customXml/item3.xml><?xml version="1.0" encoding="utf-8"?>
 <ct:contentTypeSchema xmlns:ct="http://schemas.microsoft.com/office/2006/metadata/contentType" xmlns:ma="http://schemas.microsoft.com/office/2006/metadata/properties/metaAttributes" ct:_="" ma:_="" ma:contentTypeName="ドキュメント" ma:contentTypeID="0x01010078CA3DF7EA5DCB4696D50A178692CD6B" ma:contentTypeVersion="14" ma:contentTypeDescription="新しいドキュメントを作成します。" ma:contentTypeScope="" ma:versionID="ca8f3eb4a18a43d95edeb9cf328e3d26">
   <xsd:schema xmlns:xsd="http://www.w3.org/2001/XMLSchema" xmlns:xs="http://www.w3.org/2001/XMLSchema" xmlns:p="http://schemas.microsoft.com/office/2006/metadata/properties" xmlns:ns2="fda3c21f-1c89-4c79-bdc1-51a203d16466" xmlns:ns3="32cc87eb-95ee-46b2-8a4f-e4c19d67f474" targetNamespace="http://schemas.microsoft.com/office/2006/metadata/properties" ma:root="true" ma:fieldsID="452a6a1abf5e07dad38d19a068a0d606" ns2:_="" ns3:_="">
     <xsd:import namespace="fda3c21f-1c89-4c79-bdc1-51a203d16466"/>
@@ -24267,27 +24287,34 @@
 </ct:contentTypeSchema>
 </file>
 
-<file path=customXml/item2.xml><?xml version="1.0" encoding="utf-8"?>
-<?mso-contentType ?>
-<FormTemplates xmlns="http://schemas.microsoft.com/sharepoint/v3/contenttype/forms">
-  <Display>DocumentLibraryForm</Display>
-  <Edit>DocumentLibraryForm</Edit>
-  <New>DocumentLibraryForm</New>
-</FormTemplates>
+<file path=customXml/itemProps1.xml><?xml version="1.0" encoding="utf-8"?>
+<ds:datastoreItem xmlns:ds="http://schemas.openxmlformats.org/officeDocument/2006/customXml" ds:itemID="{45CE051D-E410-436D-B4DC-DDC5DE3A8A39}">
+  <ds:schemaRefs>
+    <ds:schemaRef ds:uri="http://schemas.microsoft.com/office/2006/documentManagement/types"/>
+    <ds:schemaRef ds:uri="http://schemas.microsoft.com/office/infopath/2007/PartnerControls"/>
+    <ds:schemaRef ds:uri="54a5dc5c-33ae-4aa5-bfd3-6947018d41dc"/>
+    <ds:schemaRef ds:uri="http://purl.org/dc/elements/1.1/"/>
+    <ds:schemaRef ds:uri="http://schemas.microsoft.com/office/2006/metadata/properties"/>
+    <ds:schemaRef ds:uri="http://purl.org/dc/terms/"/>
+    <ds:schemaRef ds:uri="http://schemas.openxmlformats.org/package/2006/metadata/core-properties"/>
+    <ds:schemaRef ds:uri="70fa4a48-2d82-4cae-9908-0b599a5c0b57"/>
+    <ds:schemaRef ds:uri="http://www.w3.org/XML/1998/namespace"/>
+    <ds:schemaRef ds:uri="http://purl.org/dc/dcmitype/"/>
+    <ds:schemaRef ds:uri="fda3c21f-1c89-4c79-bdc1-51a203d16466"/>
+    <ds:schemaRef ds:uri="32cc87eb-95ee-46b2-8a4f-e4c19d67f474"/>
+  </ds:schemaRefs>
+</ds:datastoreItem>
 </file>
 
-<file path=customXml/item3.xml><?xml version="1.0" encoding="utf-8"?>
-<p:properties xmlns:p="http://schemas.microsoft.com/office/2006/metadata/properties" xmlns:xsi="http://www.w3.org/2001/XMLSchema-instance" xmlns:pc="http://schemas.microsoft.com/office/infopath/2007/PartnerControls">
-  <documentManagement>
-    <lcf76f155ced4ddcb4097134ff3c332f xmlns="fda3c21f-1c89-4c79-bdc1-51a203d16466">
-      <Terms xmlns="http://schemas.microsoft.com/office/infopath/2007/PartnerControls"/>
-    </lcf76f155ced4ddcb4097134ff3c332f>
-    <TaxCatchAll xmlns="32cc87eb-95ee-46b2-8a4f-e4c19d67f474" xsi:nil="true"/>
-  </documentManagement>
-</p:properties>
+<file path=customXml/itemProps2.xml><?xml version="1.0" encoding="utf-8"?>
+<ds:datastoreItem xmlns:ds="http://schemas.openxmlformats.org/officeDocument/2006/customXml" ds:itemID="{E26A0283-E002-4988-B9E2-985FB616218F}">
+  <ds:schemaRefs>
+    <ds:schemaRef ds:uri="http://schemas.microsoft.com/sharepoint/v3/contenttype/forms"/>
+  </ds:schemaRefs>
+</ds:datastoreItem>
 </file>
 
-<file path=customXml/itemProps1.xml><?xml version="1.0" encoding="utf-8"?>
+<file path=customXml/itemProps3.xml><?xml version="1.0" encoding="utf-8"?>
 <ds:datastoreItem xmlns:ds="http://schemas.openxmlformats.org/officeDocument/2006/customXml" ds:itemID="{4404F269-6B86-47A8-B9AA-209F0E4605B6}">
   <ds:schemaRefs>
     <ds:schemaRef ds:uri="http://schemas.microsoft.com/office/2006/metadata/contentType"/>
@@ -24304,31 +24331,4 @@
     <ds:schemaRef ds:uri="http://schemas.microsoft.com/internal/obd"/>
   </ds:schemaRefs>
 </ds:datastoreItem>
-</file>
-
-<file path=customXml/itemProps2.xml><?xml version="1.0" encoding="utf-8"?>
-<ds:datastoreItem xmlns:ds="http://schemas.openxmlformats.org/officeDocument/2006/customXml" ds:itemID="{E26A0283-E002-4988-B9E2-985FB616218F}">
-  <ds:schemaRefs>
-    <ds:schemaRef ds:uri="http://schemas.microsoft.com/sharepoint/v3/contenttype/forms"/>
-  </ds:schemaRefs>
-</ds:datastoreItem>
-</file>
-
-<file path=customXml/itemProps3.xml><?xml version="1.0" encoding="utf-8"?>
-<ds:datastoreItem xmlns:ds="http://schemas.openxmlformats.org/officeDocument/2006/customXml" ds:itemID="{45CE051D-E410-436D-B4DC-DDC5DE3A8A39}">
-  <ds:schemaRefs>
-    <ds:schemaRef ds:uri="http://schemas.microsoft.com/office/2006/documentManagement/types"/>
-    <ds:schemaRef ds:uri="http://schemas.microsoft.com/office/infopath/2007/PartnerControls"/>
-    <ds:schemaRef ds:uri="54a5dc5c-33ae-4aa5-bfd3-6947018d41dc"/>
-    <ds:schemaRef ds:uri="http://purl.org/dc/elements/1.1/"/>
-    <ds:schemaRef ds:uri="http://schemas.microsoft.com/office/2006/metadata/properties"/>
-    <ds:schemaRef ds:uri="http://purl.org/dc/terms/"/>
-    <ds:schemaRef ds:uri="http://schemas.openxmlformats.org/package/2006/metadata/core-properties"/>
-    <ds:schemaRef ds:uri="70fa4a48-2d82-4cae-9908-0b599a5c0b57"/>
-    <ds:schemaRef ds:uri="http://www.w3.org/XML/1998/namespace"/>
-    <ds:schemaRef ds:uri="http://purl.org/dc/dcmitype/"/>
-    <ds:schemaRef ds:uri="fda3c21f-1c89-4c79-bdc1-51a203d16466"/>
-    <ds:schemaRef ds:uri="32cc87eb-95ee-46b2-8a4f-e4c19d67f474"/>
-  </ds:schemaRefs>
-</ds:datastoreItem>
 </file>
</xml_diff>